<commit_message>
부가 실험: RAG(BM25 few-shot) vs QLoRA 비교 추가
사전등록된 R0~R4 비교와는 별개로, 파인튜닝 없이 학습 도메인 문서를 BM25로
검색해 few-shot으로 넣는 방식이 QLoRA를 대체할 수 있는지 3B 모델로만
검증했다(검색은 결정론적이라 방향당 1회). R2보다는 훨씬 낫지만 R3/R4에는
못 미치고 R0 수준에 머무른다 — 구조화 형식에 맞춘 가중치 갱신 자체가
검색만으로는 대체되지 않는다는 근거.

- run_rag_eval.py: BM25 검색 + few-shot 프롬프트 + 기존 채점 파이프라인 재사용
- rag_results.csv: forum/literature 양방향 결과
- presentation.pptx/script: 부가 실험 슬라이드(10번) 추가, 11장 구성으로 갱신
- README: 결과 요약에 RAG 비교 반영

Co-Authored-By: Claude Sonnet 5 <noreply@anthropic.com>
</commit_message>
<xml_diff>
--- a/research-project/reports/presentation.pptx
+++ b/research-project/reports/presentation.pptx
@@ -15,6 +15,7 @@
     <p:sldId id="263" r:id="rId14"/>
     <p:sldId id="264" r:id="rId15"/>
     <p:sldId id="265" r:id="rId16"/>
+    <p:sldId id="266" r:id="rId17"/>
   </p:sldIdLst>
   <p:sldSz cx="12191695" cy="6858000" type="screen4x3"/>
   <p:notesSz cx="6858000" cy="9144000"/>
@@ -4219,7 +4220,7 @@
                 </a:solidFill>
                 <a:latin typeface="Consolas"/>
               </a:rPr>
-              <a:t>/ 10</a:t>
+              <a:t>/ 11</a:t>
             </a:r>
           </a:p>
         </p:txBody>
@@ -4512,14 +4513,502 @@
                 </a:solidFill>
                 <a:latin typeface="Calibri"/>
               </a:rPr>
-              <a:t>결 론</a:t>
-            </a:r>
-          </a:p>
-        </p:txBody>
-      </p:sp>
-      <p:sp>
-        <p:nvSpPr>
-          <p:cNvPr id="4" name="TextBox 3"/>
+              <a:t>부 가   실 험</a:t>
+            </a:r>
+          </a:p>
+        </p:txBody>
+      </p:sp>
+      <p:sp>
+        <p:nvSpPr>
+          <p:cNvPr id="4" name="Rectangle 3"/>
+          <p:cNvSpPr/>
+          <p:nvPr/>
+        </p:nvSpPr>
+        <p:spPr>
+          <a:xfrm>
+            <a:off x="292608" y="2066544"/>
+            <a:ext cx="146304" cy="146304"/>
+          </a:xfrm>
+          <a:prstGeom prst="rect">
+            <a:avLst/>
+          </a:prstGeom>
+          <a:solidFill>
+            <a:srgbClr val="9A9DA3"/>
+          </a:solidFill>
+          <a:ln>
+            <a:noFill/>
+          </a:ln>
+          <a:effectLst/>
+        </p:spPr>
+        <p:style>
+          <a:lnRef idx="1">
+            <a:schemeClr val="accent1"/>
+          </a:lnRef>
+          <a:fillRef idx="3">
+            <a:schemeClr val="accent1"/>
+          </a:fillRef>
+          <a:effectRef idx="2">
+            <a:schemeClr val="accent1"/>
+          </a:effectRef>
+          <a:fontRef idx="minor">
+            <a:schemeClr val="lt1"/>
+          </a:fontRef>
+        </p:style>
+        <p:txBody>
+          <a:bodyPr rtlCol="0" anchor="ctr"/>
+          <a:lstStyle/>
+          <a:p>
+            <a:pPr algn="ctr"/>
+          </a:p>
+        </p:txBody>
+      </p:sp>
+      <p:sp>
+        <p:nvSpPr>
+          <p:cNvPr id="5" name="TextBox 4"/>
+          <p:cNvSpPr txBox="1"/>
+          <p:nvPr/>
+        </p:nvSpPr>
+        <p:spPr>
+          <a:xfrm>
+            <a:off x="530352" y="2011680"/>
+            <a:ext cx="1188720" cy="365760"/>
+          </a:xfrm>
+          <a:prstGeom prst="rect">
+            <a:avLst/>
+          </a:prstGeom>
+          <a:noFill/>
+        </p:spPr>
+        <p:txBody>
+          <a:bodyPr wrap="square">
+            <a:spAutoFit/>
+          </a:bodyPr>
+          <a:lstStyle/>
+          <a:p>
+            <a:pPr algn="l">
+              <a:lnSpc>
+                <a:spcPct val="115000"/>
+              </a:lnSpc>
+            </a:pPr>
+            <a:r>
+              <a:rPr sz="1250" b="1" i="0">
+                <a:solidFill>
+                  <a:srgbClr val="FFFFFF"/>
+                </a:solidFill>
+                <a:latin typeface="Consolas"/>
+              </a:rPr>
+              <a:t>R0</a:t>
+            </a:r>
+          </a:p>
+        </p:txBody>
+      </p:sp>
+      <p:sp>
+        <p:nvSpPr>
+          <p:cNvPr id="6" name="TextBox 5"/>
+          <p:cNvSpPr txBox="1"/>
+          <p:nvPr/>
+        </p:nvSpPr>
+        <p:spPr>
+          <a:xfrm>
+            <a:off x="530352" y="2249424"/>
+            <a:ext cx="1188720" cy="320040"/>
+          </a:xfrm>
+          <a:prstGeom prst="rect">
+            <a:avLst/>
+          </a:prstGeom>
+          <a:noFill/>
+        </p:spPr>
+        <p:txBody>
+          <a:bodyPr wrap="square">
+            <a:spAutoFit/>
+          </a:bodyPr>
+          <a:lstStyle/>
+          <a:p>
+            <a:pPr algn="l">
+              <a:lnSpc>
+                <a:spcPct val="115000"/>
+              </a:lnSpc>
+            </a:pPr>
+            <a:r>
+              <a:rPr sz="950" b="0" i="0">
+                <a:solidFill>
+                  <a:srgbClr val="8B908E"/>
+                </a:solidFill>
+                <a:latin typeface="Calibri"/>
+              </a:rPr>
+              <a:t>원문 그대로</a:t>
+            </a:r>
+          </a:p>
+        </p:txBody>
+      </p:sp>
+      <p:sp>
+        <p:nvSpPr>
+          <p:cNvPr id="7" name="Rectangle 6"/>
+          <p:cNvSpPr/>
+          <p:nvPr/>
+        </p:nvSpPr>
+        <p:spPr>
+          <a:xfrm>
+            <a:off x="292608" y="2633472"/>
+            <a:ext cx="146304" cy="146304"/>
+          </a:xfrm>
+          <a:prstGeom prst="rect">
+            <a:avLst/>
+          </a:prstGeom>
+          <a:solidFill>
+            <a:srgbClr val="C98A54"/>
+          </a:solidFill>
+          <a:ln>
+            <a:noFill/>
+          </a:ln>
+          <a:effectLst/>
+        </p:spPr>
+        <p:style>
+          <a:lnRef idx="1">
+            <a:schemeClr val="accent1"/>
+          </a:lnRef>
+          <a:fillRef idx="3">
+            <a:schemeClr val="accent1"/>
+          </a:fillRef>
+          <a:effectRef idx="2">
+            <a:schemeClr val="accent1"/>
+          </a:effectRef>
+          <a:fontRef idx="minor">
+            <a:schemeClr val="lt1"/>
+          </a:fontRef>
+        </p:style>
+        <p:txBody>
+          <a:bodyPr rtlCol="0" anchor="ctr"/>
+          <a:lstStyle/>
+          <a:p>
+            <a:pPr algn="ctr"/>
+          </a:p>
+        </p:txBody>
+      </p:sp>
+      <p:sp>
+        <p:nvSpPr>
+          <p:cNvPr id="8" name="TextBox 7"/>
+          <p:cNvSpPr txBox="1"/>
+          <p:nvPr/>
+        </p:nvSpPr>
+        <p:spPr>
+          <a:xfrm>
+            <a:off x="530352" y="2578608"/>
+            <a:ext cx="1188720" cy="365760"/>
+          </a:xfrm>
+          <a:prstGeom prst="rect">
+            <a:avLst/>
+          </a:prstGeom>
+          <a:noFill/>
+        </p:spPr>
+        <p:txBody>
+          <a:bodyPr wrap="square">
+            <a:spAutoFit/>
+          </a:bodyPr>
+          <a:lstStyle/>
+          <a:p>
+            <a:pPr algn="l">
+              <a:lnSpc>
+                <a:spcPct val="115000"/>
+              </a:lnSpc>
+            </a:pPr>
+            <a:r>
+              <a:rPr sz="1250" b="1" i="0">
+                <a:solidFill>
+                  <a:srgbClr val="FFFFFF"/>
+                </a:solidFill>
+                <a:latin typeface="Consolas"/>
+              </a:rPr>
+              <a:t>R2</a:t>
+            </a:r>
+          </a:p>
+        </p:txBody>
+      </p:sp>
+      <p:sp>
+        <p:nvSpPr>
+          <p:cNvPr id="9" name="TextBox 8"/>
+          <p:cNvSpPr txBox="1"/>
+          <p:nvPr/>
+        </p:nvSpPr>
+        <p:spPr>
+          <a:xfrm>
+            <a:off x="530352" y="2816352"/>
+            <a:ext cx="1188720" cy="320040"/>
+          </a:xfrm>
+          <a:prstGeom prst="rect">
+            <a:avLst/>
+          </a:prstGeom>
+          <a:noFill/>
+        </p:spPr>
+        <p:txBody>
+          <a:bodyPr wrap="square">
+            <a:spAutoFit/>
+          </a:bodyPr>
+          <a:lstStyle/>
+          <a:p>
+            <a:pPr algn="l">
+              <a:lnSpc>
+                <a:spcPct val="115000"/>
+              </a:lnSpc>
+            </a:pPr>
+            <a:r>
+              <a:rPr sz="950" b="0" i="0">
+                <a:solidFill>
+                  <a:srgbClr val="8B908E"/>
+                </a:solidFill>
+                <a:latin typeface="Calibri"/>
+              </a:rPr>
+              <a:t>자유서술</a:t>
+            </a:r>
+          </a:p>
+        </p:txBody>
+      </p:sp>
+      <p:sp>
+        <p:nvSpPr>
+          <p:cNvPr id="10" name="Rectangle 9"/>
+          <p:cNvSpPr/>
+          <p:nvPr/>
+        </p:nvSpPr>
+        <p:spPr>
+          <a:xfrm>
+            <a:off x="292608" y="3200400"/>
+            <a:ext cx="146304" cy="146304"/>
+          </a:xfrm>
+          <a:prstGeom prst="rect">
+            <a:avLst/>
+          </a:prstGeom>
+          <a:solidFill>
+            <a:srgbClr val="4C8C7E"/>
+          </a:solidFill>
+          <a:ln>
+            <a:noFill/>
+          </a:ln>
+          <a:effectLst/>
+        </p:spPr>
+        <p:style>
+          <a:lnRef idx="1">
+            <a:schemeClr val="accent1"/>
+          </a:lnRef>
+          <a:fillRef idx="3">
+            <a:schemeClr val="accent1"/>
+          </a:fillRef>
+          <a:effectRef idx="2">
+            <a:schemeClr val="accent1"/>
+          </a:effectRef>
+          <a:fontRef idx="minor">
+            <a:schemeClr val="lt1"/>
+          </a:fontRef>
+        </p:style>
+        <p:txBody>
+          <a:bodyPr rtlCol="0" anchor="ctr"/>
+          <a:lstStyle/>
+          <a:p>
+            <a:pPr algn="ctr"/>
+          </a:p>
+        </p:txBody>
+      </p:sp>
+      <p:sp>
+        <p:nvSpPr>
+          <p:cNvPr id="11" name="TextBox 10"/>
+          <p:cNvSpPr txBox="1"/>
+          <p:nvPr/>
+        </p:nvSpPr>
+        <p:spPr>
+          <a:xfrm>
+            <a:off x="530352" y="3145536"/>
+            <a:ext cx="1188720" cy="365760"/>
+          </a:xfrm>
+          <a:prstGeom prst="rect">
+            <a:avLst/>
+          </a:prstGeom>
+          <a:noFill/>
+        </p:spPr>
+        <p:txBody>
+          <a:bodyPr wrap="square">
+            <a:spAutoFit/>
+          </a:bodyPr>
+          <a:lstStyle/>
+          <a:p>
+            <a:pPr algn="l">
+              <a:lnSpc>
+                <a:spcPct val="115000"/>
+              </a:lnSpc>
+            </a:pPr>
+            <a:r>
+              <a:rPr sz="1250" b="1" i="0">
+                <a:solidFill>
+                  <a:srgbClr val="FFFFFF"/>
+                </a:solidFill>
+                <a:latin typeface="Consolas"/>
+              </a:rPr>
+              <a:t>R3</a:t>
+            </a:r>
+          </a:p>
+        </p:txBody>
+      </p:sp>
+      <p:sp>
+        <p:nvSpPr>
+          <p:cNvPr id="12" name="TextBox 11"/>
+          <p:cNvSpPr txBox="1"/>
+          <p:nvPr/>
+        </p:nvSpPr>
+        <p:spPr>
+          <a:xfrm>
+            <a:off x="530352" y="3383280"/>
+            <a:ext cx="1188720" cy="320040"/>
+          </a:xfrm>
+          <a:prstGeom prst="rect">
+            <a:avLst/>
+          </a:prstGeom>
+          <a:noFill/>
+        </p:spPr>
+        <p:txBody>
+          <a:bodyPr wrap="square">
+            <a:spAutoFit/>
+          </a:bodyPr>
+          <a:lstStyle/>
+          <a:p>
+            <a:pPr algn="l">
+              <a:lnSpc>
+                <a:spcPct val="115000"/>
+              </a:lnSpc>
+            </a:pPr>
+            <a:r>
+              <a:rPr sz="950" b="0" i="0">
+                <a:solidFill>
+                  <a:srgbClr val="8B908E"/>
+                </a:solidFill>
+                <a:latin typeface="Calibri"/>
+              </a:rPr>
+              <a:t>구조화</a:t>
+            </a:r>
+          </a:p>
+        </p:txBody>
+      </p:sp>
+      <p:sp>
+        <p:nvSpPr>
+          <p:cNvPr id="13" name="Rectangle 12"/>
+          <p:cNvSpPr/>
+          <p:nvPr/>
+        </p:nvSpPr>
+        <p:spPr>
+          <a:xfrm>
+            <a:off x="292608" y="3767328"/>
+            <a:ext cx="146304" cy="146304"/>
+          </a:xfrm>
+          <a:prstGeom prst="rect">
+            <a:avLst/>
+          </a:prstGeom>
+          <a:solidFill>
+            <a:srgbClr val="8A74B0"/>
+          </a:solidFill>
+          <a:ln>
+            <a:noFill/>
+          </a:ln>
+          <a:effectLst/>
+        </p:spPr>
+        <p:style>
+          <a:lnRef idx="1">
+            <a:schemeClr val="accent1"/>
+          </a:lnRef>
+          <a:fillRef idx="3">
+            <a:schemeClr val="accent1"/>
+          </a:fillRef>
+          <a:effectRef idx="2">
+            <a:schemeClr val="accent1"/>
+          </a:effectRef>
+          <a:fontRef idx="minor">
+            <a:schemeClr val="lt1"/>
+          </a:fontRef>
+        </p:style>
+        <p:txBody>
+          <a:bodyPr rtlCol="0" anchor="ctr"/>
+          <a:lstStyle/>
+          <a:p>
+            <a:pPr algn="ctr"/>
+          </a:p>
+        </p:txBody>
+      </p:sp>
+      <p:sp>
+        <p:nvSpPr>
+          <p:cNvPr id="14" name="TextBox 13"/>
+          <p:cNvSpPr txBox="1"/>
+          <p:nvPr/>
+        </p:nvSpPr>
+        <p:spPr>
+          <a:xfrm>
+            <a:off x="530352" y="3712464"/>
+            <a:ext cx="1188720" cy="365760"/>
+          </a:xfrm>
+          <a:prstGeom prst="rect">
+            <a:avLst/>
+          </a:prstGeom>
+          <a:noFill/>
+        </p:spPr>
+        <p:txBody>
+          <a:bodyPr wrap="square">
+            <a:spAutoFit/>
+          </a:bodyPr>
+          <a:lstStyle/>
+          <a:p>
+            <a:pPr algn="l">
+              <a:lnSpc>
+                <a:spcPct val="115000"/>
+              </a:lnSpc>
+            </a:pPr>
+            <a:r>
+              <a:rPr sz="1250" b="1" i="0">
+                <a:solidFill>
+                  <a:srgbClr val="FFFFFF"/>
+                </a:solidFill>
+                <a:latin typeface="Consolas"/>
+              </a:rPr>
+              <a:t>R4</a:t>
+            </a:r>
+          </a:p>
+        </p:txBody>
+      </p:sp>
+      <p:sp>
+        <p:nvSpPr>
+          <p:cNvPr id="15" name="TextBox 14"/>
+          <p:cNvSpPr txBox="1"/>
+          <p:nvPr/>
+        </p:nvSpPr>
+        <p:spPr>
+          <a:xfrm>
+            <a:off x="530352" y="3950208"/>
+            <a:ext cx="1188720" cy="320040"/>
+          </a:xfrm>
+          <a:prstGeom prst="rect">
+            <a:avLst/>
+          </a:prstGeom>
+          <a:noFill/>
+        </p:spPr>
+        <p:txBody>
+          <a:bodyPr wrap="square">
+            <a:spAutoFit/>
+          </a:bodyPr>
+          <a:lstStyle/>
+          <a:p>
+            <a:pPr algn="l">
+              <a:lnSpc>
+                <a:spcPct val="115000"/>
+              </a:lnSpc>
+            </a:pPr>
+            <a:r>
+              <a:rPr sz="950" b="0" i="0">
+                <a:solidFill>
+                  <a:srgbClr val="8B908E"/>
+                </a:solidFill>
+                <a:latin typeface="Calibri"/>
+              </a:rPr>
+              <a:t>구조화+판단</a:t>
+            </a:r>
+          </a:p>
+        </p:txBody>
+      </p:sp>
+      <p:sp>
+        <p:nvSpPr>
+          <p:cNvPr id="16" name="TextBox 15"/>
           <p:cNvSpPr txBox="1"/>
           <p:nvPr/>
         </p:nvSpPr>
@@ -4558,7 +5047,7 @@
       </p:sp>
       <p:sp>
         <p:nvSpPr>
-          <p:cNvPr id="5" name="TextBox 4"/>
+          <p:cNvPr id="17" name="TextBox 16"/>
           <p:cNvSpPr txBox="1"/>
           <p:nvPr/>
         </p:nvSpPr>
@@ -4590,7 +5079,1023 @@
                 </a:solidFill>
                 <a:latin typeface="Consolas"/>
               </a:rPr>
-              <a:t>/ 10</a:t>
+              <a:t>/ 11</a:t>
+            </a:r>
+          </a:p>
+        </p:txBody>
+      </p:sp>
+      <p:sp>
+        <p:nvSpPr>
+          <p:cNvPr id="18" name="TextBox 17"/>
+          <p:cNvSpPr txBox="1"/>
+          <p:nvPr/>
+        </p:nvSpPr>
+        <p:spPr>
+          <a:xfrm>
+            <a:off x="2194560" y="566928"/>
+            <a:ext cx="9357055" cy="914400"/>
+          </a:xfrm>
+          <a:prstGeom prst="rect">
+            <a:avLst/>
+          </a:prstGeom>
+          <a:noFill/>
+        </p:spPr>
+        <p:txBody>
+          <a:bodyPr wrap="square">
+            <a:spAutoFit/>
+          </a:bodyPr>
+          <a:lstStyle/>
+          <a:p>
+            <a:pPr algn="l">
+              <a:lnSpc>
+                <a:spcPct val="108000"/>
+              </a:lnSpc>
+            </a:pPr>
+            <a:r>
+              <a:rPr sz="2300" b="1" i="0">
+                <a:solidFill>
+                  <a:srgbClr val="17181A"/>
+                </a:solidFill>
+                <a:latin typeface="Cambria"/>
+              </a:rPr>
+              <a:t>검색 기반(RAG)은 파인튜닝을 대체하지 못한다</a:t>
+            </a:r>
+          </a:p>
+        </p:txBody>
+      </p:sp>
+      <p:cxnSp>
+        <p:nvCxnSpPr>
+          <p:cNvPr id="19" name="Connector 18"/>
+          <p:cNvCxnSpPr/>
+          <p:nvPr/>
+        </p:nvCxnSpPr>
+        <p:spPr>
+          <a:xfrm>
+            <a:off x="2194560" y="1371600"/>
+            <a:ext cx="9357055" cy="0"/>
+          </a:xfrm>
+          <a:prstGeom prst="line">
+            <a:avLst/>
+          </a:prstGeom>
+          <a:ln w="13970">
+            <a:solidFill>
+              <a:srgbClr val="17181A"/>
+            </a:solidFill>
+          </a:ln>
+        </p:spPr>
+        <p:style>
+          <a:lnRef idx="2">
+            <a:schemeClr val="accent1"/>
+          </a:lnRef>
+          <a:fillRef idx="0">
+            <a:schemeClr val="accent1"/>
+          </a:fillRef>
+          <a:effectRef idx="1">
+            <a:schemeClr val="accent1"/>
+          </a:effectRef>
+          <a:fontRef idx="minor">
+            <a:schemeClr val="tx1"/>
+          </a:fontRef>
+        </p:style>
+      </p:cxnSp>
+      <p:sp>
+        <p:nvSpPr>
+          <p:cNvPr id="20" name="TextBox 19"/>
+          <p:cNvSpPr txBox="1"/>
+          <p:nvPr/>
+        </p:nvSpPr>
+        <p:spPr>
+          <a:xfrm>
+            <a:off x="2194560" y="1691640"/>
+            <a:ext cx="9357055" cy="640080"/>
+          </a:xfrm>
+          <a:prstGeom prst="rect">
+            <a:avLst/>
+          </a:prstGeom>
+          <a:noFill/>
+        </p:spPr>
+        <p:txBody>
+          <a:bodyPr wrap="square">
+            <a:spAutoFit/>
+          </a:bodyPr>
+          <a:lstStyle/>
+          <a:p>
+            <a:pPr algn="l">
+              <a:lnSpc>
+                <a:spcPct val="130000"/>
+              </a:lnSpc>
+            </a:pPr>
+            <a:r>
+              <a:rPr sz="1250" b="0" i="0">
+                <a:solidFill>
+                  <a:srgbClr val="747066"/>
+                </a:solidFill>
+                <a:latin typeface="Calibri"/>
+              </a:rPr>
+              <a:t>파인튜닝 없이 학습 도메인 문서 + R3 교사 출력을 BM25로 검색해 k=3 few-shot으로 넣고</a:t>
+            </a:r>
+          </a:p>
+          <a:p>
+            <a:pPr algn="l">
+              <a:lnSpc>
+                <a:spcPct val="130000"/>
+              </a:lnSpc>
+            </a:pPr>
+            <a:r>
+              <a:rPr sz="1250" b="0" i="0">
+                <a:solidFill>
+                  <a:srgbClr val="747066"/>
+                </a:solidFill>
+                <a:latin typeface="Calibri"/>
+              </a:rPr>
+              <a:t>베이스 3B 모델로 R3 형식을 흉내낸 결과 (검색은 결정론적이라 시드 없이 방향당 1회).</a:t>
+            </a:r>
+          </a:p>
+        </p:txBody>
+      </p:sp>
+      <p:graphicFrame>
+        <p:nvGraphicFramePr>
+          <p:cNvPr id="21" name="Table 20"/>
+          <p:cNvGraphicFramePr>
+            <a:graphicFrameLocks noGrp="1"/>
+          </p:cNvGraphicFramePr>
+          <p:nvPr/>
+        </p:nvGraphicFramePr>
+        <p:xfrm>
+          <a:off x="2194560" y="2514600"/>
+          <a:ext cx="9509760" cy="1508760"/>
+        </p:xfrm>
+        <a:graphic>
+          <a:graphicData uri="http://schemas.openxmlformats.org/drawingml/2006/table">
+            <a:tbl>
+              <a:tblPr bandRow="1">
+                <a:tableStyleId>{5C22544A-7EE6-4342-B048-85BDC9FD1C3A}</a:tableStyleId>
+              </a:tblPr>
+              <a:tblGrid>
+                <a:gridCol w="2377440"/>
+                <a:gridCol w="1463040"/>
+                <a:gridCol w="1463040"/>
+                <a:gridCol w="1828800"/>
+                <a:gridCol w="2377440"/>
+              </a:tblGrid>
+              <a:tr h="502920">
+                <a:tc>
+                  <a:txBody>
+                    <a:bodyPr/>
+                    <a:lstStyle/>
+                    <a:p>
+                      <a:r>
+                        <a:rPr b="1" sz="1100">
+                          <a:solidFill>
+                            <a:srgbClr val="747066"/>
+                          </a:solidFill>
+                          <a:latin typeface="Calibri"/>
+                        </a:rPr>
+                        <a:t>방향</a:t>
+                      </a:r>
+                    </a:p>
+                  </a:txBody>
+                  <a:tcPr anchor="b" marB="50800">
+                    <a:solidFill>
+                      <a:srgbClr val="F7F5F0"/>
+                    </a:solidFill>
+                  </a:tcPr>
+                </a:tc>
+                <a:tc>
+                  <a:txBody>
+                    <a:bodyPr/>
+                    <a:lstStyle/>
+                    <a:p>
+                      <a:r>
+                        <a:rPr b="1" sz="1100">
+                          <a:solidFill>
+                            <a:srgbClr val="747066"/>
+                          </a:solidFill>
+                          <a:latin typeface="Calibri"/>
+                        </a:rPr>
+                        <a:t>R0</a:t>
+                      </a:r>
+                    </a:p>
+                  </a:txBody>
+                  <a:tcPr anchor="b" marB="50800">
+                    <a:solidFill>
+                      <a:srgbClr val="F7F5F0"/>
+                    </a:solidFill>
+                  </a:tcPr>
+                </a:tc>
+                <a:tc>
+                  <a:txBody>
+                    <a:bodyPr/>
+                    <a:lstStyle/>
+                    <a:p>
+                      <a:r>
+                        <a:rPr b="1" sz="1100">
+                          <a:solidFill>
+                            <a:srgbClr val="747066"/>
+                          </a:solidFill>
+                          <a:latin typeface="Calibri"/>
+                        </a:rPr>
+                        <a:t>R2</a:t>
+                      </a:r>
+                    </a:p>
+                  </a:txBody>
+                  <a:tcPr anchor="b" marB="50800">
+                    <a:solidFill>
+                      <a:srgbClr val="F7F5F0"/>
+                    </a:solidFill>
+                  </a:tcPr>
+                </a:tc>
+                <a:tc>
+                  <a:txBody>
+                    <a:bodyPr/>
+                    <a:lstStyle/>
+                    <a:p>
+                      <a:r>
+                        <a:rPr b="1" sz="1100">
+                          <a:solidFill>
+                            <a:srgbClr val="747066"/>
+                          </a:solidFill>
+                          <a:latin typeface="Calibri"/>
+                        </a:rPr>
+                        <a:t>R3 (QLoRA)</a:t>
+                      </a:r>
+                    </a:p>
+                  </a:txBody>
+                  <a:tcPr anchor="b" marB="50800">
+                    <a:solidFill>
+                      <a:srgbClr val="F7F5F0"/>
+                    </a:solidFill>
+                  </a:tcPr>
+                </a:tc>
+                <a:tc>
+                  <a:txBody>
+                    <a:bodyPr/>
+                    <a:lstStyle/>
+                    <a:p>
+                      <a:r>
+                        <a:rPr b="1" sz="1100">
+                          <a:solidFill>
+                            <a:srgbClr val="747066"/>
+                          </a:solidFill>
+                          <a:latin typeface="Calibri"/>
+                        </a:rPr>
+                        <a:t>RAG (파인튜닝 없음)</a:t>
+                      </a:r>
+                    </a:p>
+                  </a:txBody>
+                  <a:tcPr anchor="b" marB="50800">
+                    <a:solidFill>
+                      <a:srgbClr val="F7F5F0"/>
+                    </a:solidFill>
+                  </a:tcPr>
+                </a:tc>
+              </a:tr>
+              <a:tr h="502920">
+                <a:tc>
+                  <a:txBody>
+                    <a:bodyPr/>
+                    <a:lstStyle/>
+                    <a:p>
+                      <a:r>
+                        <a:rPr sz="1400">
+                          <a:solidFill>
+                            <a:srgbClr val="17181A"/>
+                          </a:solidFill>
+                          <a:latin typeface="Calibri"/>
+                        </a:rPr>
+                        <a:t>forum → literature</a:t>
+                      </a:r>
+                    </a:p>
+                  </a:txBody>
+                  <a:tcPr anchor="ctr">
+                    <a:solidFill>
+                      <a:srgbClr val="F7F5F0"/>
+                    </a:solidFill>
+                  </a:tcPr>
+                </a:tc>
+                <a:tc>
+                  <a:txBody>
+                    <a:bodyPr/>
+                    <a:lstStyle/>
+                    <a:p>
+                      <a:r>
+                        <a:rPr sz="1400">
+                          <a:solidFill>
+                            <a:srgbClr val="17181A"/>
+                          </a:solidFill>
+                          <a:latin typeface="Calibri"/>
+                        </a:rPr>
+                        <a:t>45.6</a:t>
+                      </a:r>
+                    </a:p>
+                  </a:txBody>
+                  <a:tcPr anchor="ctr">
+                    <a:solidFill>
+                      <a:srgbClr val="F7F5F0"/>
+                    </a:solidFill>
+                  </a:tcPr>
+                </a:tc>
+                <a:tc>
+                  <a:txBody>
+                    <a:bodyPr/>
+                    <a:lstStyle/>
+                    <a:p>
+                      <a:r>
+                        <a:rPr sz="1400">
+                          <a:solidFill>
+                            <a:srgbClr val="17181A"/>
+                          </a:solidFill>
+                          <a:latin typeface="Calibri"/>
+                        </a:rPr>
+                        <a:t>10.5</a:t>
+                      </a:r>
+                    </a:p>
+                  </a:txBody>
+                  <a:tcPr anchor="ctr">
+                    <a:solidFill>
+                      <a:srgbClr val="F7F5F0"/>
+                    </a:solidFill>
+                  </a:tcPr>
+                </a:tc>
+                <a:tc>
+                  <a:txBody>
+                    <a:bodyPr/>
+                    <a:lstStyle/>
+                    <a:p>
+                      <a:r>
+                        <a:rPr sz="1400">
+                          <a:solidFill>
+                            <a:srgbClr val="17181A"/>
+                          </a:solidFill>
+                          <a:latin typeface="Calibri"/>
+                        </a:rPr>
+                        <a:t>59.5</a:t>
+                      </a:r>
+                    </a:p>
+                  </a:txBody>
+                  <a:tcPr anchor="ctr">
+                    <a:solidFill>
+                      <a:srgbClr val="F7F5F0"/>
+                    </a:solidFill>
+                  </a:tcPr>
+                </a:tc>
+                <a:tc>
+                  <a:txBody>
+                    <a:bodyPr/>
+                    <a:lstStyle/>
+                    <a:p>
+                      <a:r>
+                        <a:rPr sz="1400">
+                          <a:solidFill>
+                            <a:srgbClr val="17181A"/>
+                          </a:solidFill>
+                          <a:latin typeface="Calibri"/>
+                        </a:rPr>
+                        <a:t>38.7</a:t>
+                      </a:r>
+                    </a:p>
+                  </a:txBody>
+                  <a:tcPr anchor="ctr">
+                    <a:solidFill>
+                      <a:srgbClr val="F7F5F0"/>
+                    </a:solidFill>
+                  </a:tcPr>
+                </a:tc>
+              </a:tr>
+              <a:tr h="502920">
+                <a:tc>
+                  <a:txBody>
+                    <a:bodyPr/>
+                    <a:lstStyle/>
+                    <a:p>
+                      <a:r>
+                        <a:rPr sz="1400">
+                          <a:solidFill>
+                            <a:srgbClr val="17181A"/>
+                          </a:solidFill>
+                          <a:latin typeface="Calibri"/>
+                        </a:rPr>
+                        <a:t>literature → forum</a:t>
+                      </a:r>
+                    </a:p>
+                  </a:txBody>
+                  <a:tcPr anchor="ctr">
+                    <a:solidFill>
+                      <a:srgbClr val="F7F5F0"/>
+                    </a:solidFill>
+                  </a:tcPr>
+                </a:tc>
+                <a:tc>
+                  <a:txBody>
+                    <a:bodyPr/>
+                    <a:lstStyle/>
+                    <a:p>
+                      <a:r>
+                        <a:rPr sz="1400">
+                          <a:solidFill>
+                            <a:srgbClr val="17181A"/>
+                          </a:solidFill>
+                          <a:latin typeface="Calibri"/>
+                        </a:rPr>
+                        <a:t>11.1</a:t>
+                      </a:r>
+                    </a:p>
+                  </a:txBody>
+                  <a:tcPr anchor="ctr">
+                    <a:solidFill>
+                      <a:srgbClr val="F7F5F0"/>
+                    </a:solidFill>
+                  </a:tcPr>
+                </a:tc>
+                <a:tc>
+                  <a:txBody>
+                    <a:bodyPr/>
+                    <a:lstStyle/>
+                    <a:p>
+                      <a:r>
+                        <a:rPr sz="1400">
+                          <a:solidFill>
+                            <a:srgbClr val="17181A"/>
+                          </a:solidFill>
+                          <a:latin typeface="Calibri"/>
+                        </a:rPr>
+                        <a:t>4.9</a:t>
+                      </a:r>
+                    </a:p>
+                  </a:txBody>
+                  <a:tcPr anchor="ctr">
+                    <a:solidFill>
+                      <a:srgbClr val="F7F5F0"/>
+                    </a:solidFill>
+                  </a:tcPr>
+                </a:tc>
+                <a:tc>
+                  <a:txBody>
+                    <a:bodyPr/>
+                    <a:lstStyle/>
+                    <a:p>
+                      <a:r>
+                        <a:rPr sz="1400">
+                          <a:solidFill>
+                            <a:srgbClr val="17181A"/>
+                          </a:solidFill>
+                          <a:latin typeface="Calibri"/>
+                        </a:rPr>
+                        <a:t>20.1</a:t>
+                      </a:r>
+                    </a:p>
+                  </a:txBody>
+                  <a:tcPr anchor="ctr">
+                    <a:solidFill>
+                      <a:srgbClr val="F7F5F0"/>
+                    </a:solidFill>
+                  </a:tcPr>
+                </a:tc>
+                <a:tc>
+                  <a:txBody>
+                    <a:bodyPr/>
+                    <a:lstStyle/>
+                    <a:p>
+                      <a:r>
+                        <a:rPr sz="1400">
+                          <a:solidFill>
+                            <a:srgbClr val="17181A"/>
+                          </a:solidFill>
+                          <a:latin typeface="Calibri"/>
+                        </a:rPr>
+                        <a:t>11.6</a:t>
+                      </a:r>
+                    </a:p>
+                  </a:txBody>
+                  <a:tcPr anchor="ctr">
+                    <a:solidFill>
+                      <a:srgbClr val="F7F5F0"/>
+                    </a:solidFill>
+                  </a:tcPr>
+                </a:tc>
+              </a:tr>
+            </a:tbl>
+          </a:graphicData>
+        </a:graphic>
+      </p:graphicFrame>
+      <p:cxnSp>
+        <p:nvCxnSpPr>
+          <p:cNvPr id="22" name="Connector 21"/>
+          <p:cNvCxnSpPr/>
+          <p:nvPr/>
+        </p:nvCxnSpPr>
+        <p:spPr>
+          <a:xfrm>
+            <a:off x="2194560" y="3017520"/>
+            <a:ext cx="9357055" cy="0"/>
+          </a:xfrm>
+          <a:prstGeom prst="line">
+            <a:avLst/>
+          </a:prstGeom>
+          <a:ln w="13970">
+            <a:solidFill>
+              <a:srgbClr val="17181A"/>
+            </a:solidFill>
+          </a:ln>
+        </p:spPr>
+        <p:style>
+          <a:lnRef idx="2">
+            <a:schemeClr val="accent1"/>
+          </a:lnRef>
+          <a:fillRef idx="0">
+            <a:schemeClr val="accent1"/>
+          </a:fillRef>
+          <a:effectRef idx="1">
+            <a:schemeClr val="accent1"/>
+          </a:effectRef>
+          <a:fontRef idx="minor">
+            <a:schemeClr val="tx1"/>
+          </a:fontRef>
+        </p:style>
+      </p:cxnSp>
+      <p:cxnSp>
+        <p:nvCxnSpPr>
+          <p:cNvPr id="23" name="Connector 22"/>
+          <p:cNvCxnSpPr/>
+          <p:nvPr/>
+        </p:nvCxnSpPr>
+        <p:spPr>
+          <a:xfrm>
+            <a:off x="2194560" y="3520440"/>
+            <a:ext cx="9357055" cy="0"/>
+          </a:xfrm>
+          <a:prstGeom prst="line">
+            <a:avLst/>
+          </a:prstGeom>
+          <a:ln w="6350">
+            <a:solidFill>
+              <a:srgbClr val="D5CFC0"/>
+            </a:solidFill>
+          </a:ln>
+        </p:spPr>
+        <p:style>
+          <a:lnRef idx="2">
+            <a:schemeClr val="accent1"/>
+          </a:lnRef>
+          <a:fillRef idx="0">
+            <a:schemeClr val="accent1"/>
+          </a:fillRef>
+          <a:effectRef idx="1">
+            <a:schemeClr val="accent1"/>
+          </a:effectRef>
+          <a:fontRef idx="minor">
+            <a:schemeClr val="tx1"/>
+          </a:fontRef>
+        </p:style>
+      </p:cxnSp>
+      <p:cxnSp>
+        <p:nvCxnSpPr>
+          <p:cNvPr id="24" name="Connector 23"/>
+          <p:cNvCxnSpPr/>
+          <p:nvPr/>
+        </p:nvCxnSpPr>
+        <p:spPr>
+          <a:xfrm>
+            <a:off x="2194560" y="4023360"/>
+            <a:ext cx="9357055" cy="0"/>
+          </a:xfrm>
+          <a:prstGeom prst="line">
+            <a:avLst/>
+          </a:prstGeom>
+          <a:ln w="6350">
+            <a:solidFill>
+              <a:srgbClr val="D5CFC0"/>
+            </a:solidFill>
+          </a:ln>
+        </p:spPr>
+        <p:style>
+          <a:lnRef idx="2">
+            <a:schemeClr val="accent1"/>
+          </a:lnRef>
+          <a:fillRef idx="0">
+            <a:schemeClr val="accent1"/>
+          </a:fillRef>
+          <a:effectRef idx="1">
+            <a:schemeClr val="accent1"/>
+          </a:effectRef>
+          <a:fontRef idx="minor">
+            <a:schemeClr val="tx1"/>
+          </a:fontRef>
+        </p:style>
+      </p:cxnSp>
+      <p:sp>
+        <p:nvSpPr>
+          <p:cNvPr id="25" name="TextBox 24"/>
+          <p:cNvSpPr txBox="1"/>
+          <p:nvPr/>
+        </p:nvSpPr>
+        <p:spPr>
+          <a:xfrm>
+            <a:off x="2194560" y="4023360"/>
+            <a:ext cx="9357055" cy="365760"/>
+          </a:xfrm>
+          <a:prstGeom prst="rect">
+            <a:avLst/>
+          </a:prstGeom>
+          <a:noFill/>
+        </p:spPr>
+        <p:txBody>
+          <a:bodyPr wrap="square">
+            <a:spAutoFit/>
+          </a:bodyPr>
+          <a:lstStyle/>
+          <a:p>
+            <a:pPr algn="l">
+              <a:lnSpc>
+                <a:spcPct val="115000"/>
+              </a:lnSpc>
+            </a:pPr>
+            <a:r>
+              <a:rPr sz="1100" b="0" i="0">
+                <a:solidFill>
+                  <a:srgbClr val="747066"/>
+                </a:solidFill>
+                <a:latin typeface="Consolas"/>
+              </a:rPr>
+              <a:t>strict F1, 3B 모델 기준</a:t>
+            </a:r>
+          </a:p>
+        </p:txBody>
+      </p:sp>
+      <p:cxnSp>
+        <p:nvCxnSpPr>
+          <p:cNvPr id="26" name="Connector 25"/>
+          <p:cNvCxnSpPr/>
+          <p:nvPr/>
+        </p:nvCxnSpPr>
+        <p:spPr>
+          <a:xfrm>
+            <a:off x="2194560" y="4526280"/>
+            <a:ext cx="9357055" cy="0"/>
+          </a:xfrm>
+          <a:prstGeom prst="line">
+            <a:avLst/>
+          </a:prstGeom>
+          <a:ln w="6350">
+            <a:solidFill>
+              <a:srgbClr val="D5CFC0"/>
+            </a:solidFill>
+          </a:ln>
+        </p:spPr>
+        <p:style>
+          <a:lnRef idx="2">
+            <a:schemeClr val="accent1"/>
+          </a:lnRef>
+          <a:fillRef idx="0">
+            <a:schemeClr val="accent1"/>
+          </a:fillRef>
+          <a:effectRef idx="1">
+            <a:schemeClr val="accent1"/>
+          </a:effectRef>
+          <a:fontRef idx="minor">
+            <a:schemeClr val="tx1"/>
+          </a:fontRef>
+        </p:style>
+      </p:cxnSp>
+      <p:sp>
+        <p:nvSpPr>
+          <p:cNvPr id="27" name="TextBox 26"/>
+          <p:cNvSpPr txBox="1"/>
+          <p:nvPr/>
+        </p:nvSpPr>
+        <p:spPr>
+          <a:xfrm>
+            <a:off x="2194560" y="4754880"/>
+            <a:ext cx="274320" cy="365760"/>
+          </a:xfrm>
+          <a:prstGeom prst="rect">
+            <a:avLst/>
+          </a:prstGeom>
+          <a:noFill/>
+        </p:spPr>
+        <p:txBody>
+          <a:bodyPr wrap="square">
+            <a:spAutoFit/>
+          </a:bodyPr>
+          <a:lstStyle/>
+          <a:p>
+            <a:pPr algn="l">
+              <a:lnSpc>
+                <a:spcPct val="115000"/>
+              </a:lnSpc>
+            </a:pPr>
+            <a:r>
+              <a:rPr sz="1350" b="1" i="0">
+                <a:solidFill>
+                  <a:srgbClr val="4C8C7E"/>
+                </a:solidFill>
+                <a:latin typeface="Calibri"/>
+              </a:rPr>
+              <a:t>—</a:t>
+            </a:r>
+          </a:p>
+        </p:txBody>
+      </p:sp>
+      <p:sp>
+        <p:nvSpPr>
+          <p:cNvPr id="28" name="TextBox 27"/>
+          <p:cNvSpPr txBox="1"/>
+          <p:nvPr/>
+        </p:nvSpPr>
+        <p:spPr>
+          <a:xfrm>
+            <a:off x="2487168" y="4754880"/>
+            <a:ext cx="9064447" cy="1097280"/>
+          </a:xfrm>
+          <a:prstGeom prst="rect">
+            <a:avLst/>
+          </a:prstGeom>
+          <a:noFill/>
+        </p:spPr>
+        <p:txBody>
+          <a:bodyPr wrap="square">
+            <a:spAutoFit/>
+          </a:bodyPr>
+          <a:lstStyle/>
+          <a:p>
+            <a:pPr algn="l">
+              <a:lnSpc>
+                <a:spcPct val="128000"/>
+              </a:lnSpc>
+            </a:pPr>
+            <a:r>
+              <a:rPr sz="1350" b="0" i="0">
+                <a:solidFill>
+                  <a:srgbClr val="17181A"/>
+                </a:solidFill>
+                <a:latin typeface="Calibri"/>
+              </a:rPr>
+              <a:t>RAG는 R2보다 훨씬 낫지만 QLoRA R3/R4에는 못 미친다 — 두 방향 모두 R0와 비슷한 수준에 머문다.</a:t>
+            </a:r>
+          </a:p>
+        </p:txBody>
+      </p:sp>
+      <p:sp>
+        <p:nvSpPr>
+          <p:cNvPr id="29" name="TextBox 28"/>
+          <p:cNvSpPr txBox="1"/>
+          <p:nvPr/>
+        </p:nvSpPr>
+        <p:spPr>
+          <a:xfrm>
+            <a:off x="2194560" y="5340096"/>
+            <a:ext cx="274320" cy="365760"/>
+          </a:xfrm>
+          <a:prstGeom prst="rect">
+            <a:avLst/>
+          </a:prstGeom>
+          <a:noFill/>
+        </p:spPr>
+        <p:txBody>
+          <a:bodyPr wrap="square">
+            <a:spAutoFit/>
+          </a:bodyPr>
+          <a:lstStyle/>
+          <a:p>
+            <a:pPr algn="l">
+              <a:lnSpc>
+                <a:spcPct val="115000"/>
+              </a:lnSpc>
+            </a:pPr>
+            <a:r>
+              <a:rPr sz="1350" b="1" i="0">
+                <a:solidFill>
+                  <a:srgbClr val="4C8C7E"/>
+                </a:solidFill>
+                <a:latin typeface="Calibri"/>
+              </a:rPr>
+              <a:t>—</a:t>
+            </a:r>
+          </a:p>
+        </p:txBody>
+      </p:sp>
+      <p:sp>
+        <p:nvSpPr>
+          <p:cNvPr id="30" name="TextBox 29"/>
+          <p:cNvSpPr txBox="1"/>
+          <p:nvPr/>
+        </p:nvSpPr>
+        <p:spPr>
+          <a:xfrm>
+            <a:off x="2487168" y="5340096"/>
+            <a:ext cx="9064447" cy="1097280"/>
+          </a:xfrm>
+          <a:prstGeom prst="rect">
+            <a:avLst/>
+          </a:prstGeom>
+          <a:noFill/>
+        </p:spPr>
+        <p:txBody>
+          <a:bodyPr wrap="square">
+            <a:spAutoFit/>
+          </a:bodyPr>
+          <a:lstStyle/>
+          <a:p>
+            <a:pPr algn="l">
+              <a:lnSpc>
+                <a:spcPct val="128000"/>
+              </a:lnSpc>
+            </a:pPr>
+            <a:r>
+              <a:rPr sz="1350" b="0" i="0">
+                <a:solidFill>
+                  <a:srgbClr val="17181A"/>
+                </a:solidFill>
+                <a:latin typeface="Calibri"/>
+              </a:rPr>
+              <a:t>검색된 예시가 형식을 흉내내는 데는 도움을 주지만, 가중치 자체를 갱신하는 QLoRA만큼의 이득은 주지 못한다.</a:t>
+            </a:r>
+          </a:p>
+        </p:txBody>
+      </p:sp>
+    </p:spTree>
+  </p:cSld>
+  <p:clrMapOvr>
+    <a:masterClrMapping/>
+  </p:clrMapOvr>
+</p:sld>
+</file>
+
+<file path=ppt/slides/slide11.xml><?xml version="1.0" encoding="utf-8"?>
+<p:sld xmlns:a="http://schemas.openxmlformats.org/drawingml/2006/main" xmlns:p="http://schemas.openxmlformats.org/presentationml/2006/main" xmlns:r="http://schemas.openxmlformats.org/officeDocument/2006/relationships">
+  <p:cSld>
+    <p:bg>
+      <p:bgPr>
+        <a:solidFill>
+          <a:srgbClr val="F7F5F0"/>
+        </a:solidFill>
+        <a:effectLst/>
+      </p:bgPr>
+    </p:bg>
+    <p:spTree>
+      <p:nvGrpSpPr>
+        <p:cNvPr id="1" name=""/>
+        <p:cNvGrpSpPr/>
+        <p:nvPr/>
+      </p:nvGrpSpPr>
+      <p:grpSpPr/>
+      <p:sp>
+        <p:nvSpPr>
+          <p:cNvPr id="2" name="Rectangle 1"/>
+          <p:cNvSpPr/>
+          <p:nvPr/>
+        </p:nvSpPr>
+        <p:spPr>
+          <a:xfrm>
+            <a:off x="0" y="0"/>
+            <a:ext cx="1783080" cy="6858000"/>
+          </a:xfrm>
+          <a:prstGeom prst="rect">
+            <a:avLst/>
+          </a:prstGeom>
+          <a:solidFill>
+            <a:srgbClr val="17181A"/>
+          </a:solidFill>
+          <a:ln>
+            <a:noFill/>
+          </a:ln>
+          <a:effectLst/>
+        </p:spPr>
+        <p:style>
+          <a:lnRef idx="1">
+            <a:schemeClr val="accent1"/>
+          </a:lnRef>
+          <a:fillRef idx="3">
+            <a:schemeClr val="accent1"/>
+          </a:fillRef>
+          <a:effectRef idx="2">
+            <a:schemeClr val="accent1"/>
+          </a:effectRef>
+          <a:fontRef idx="minor">
+            <a:schemeClr val="lt1"/>
+          </a:fontRef>
+        </p:style>
+        <p:txBody>
+          <a:bodyPr rtlCol="0" anchor="ctr"/>
+          <a:lstStyle/>
+          <a:p>
+            <a:pPr algn="ctr"/>
+          </a:p>
+        </p:txBody>
+      </p:sp>
+      <p:sp>
+        <p:nvSpPr>
+          <p:cNvPr id="3" name="TextBox 2"/>
+          <p:cNvSpPr txBox="1"/>
+          <p:nvPr/>
+        </p:nvSpPr>
+        <p:spPr>
+          <a:xfrm>
+            <a:off x="292608" y="457200"/>
+            <a:ext cx="1280160" cy="1280160"/>
+          </a:xfrm>
+          <a:prstGeom prst="rect">
+            <a:avLst/>
+          </a:prstGeom>
+          <a:noFill/>
+        </p:spPr>
+        <p:txBody>
+          <a:bodyPr wrap="square">
+            <a:spAutoFit/>
+          </a:bodyPr>
+          <a:lstStyle/>
+          <a:p>
+            <a:pPr algn="l">
+              <a:lnSpc>
+                <a:spcPct val="135000"/>
+              </a:lnSpc>
+            </a:pPr>
+            <a:r>
+              <a:rPr sz="1150" b="1" i="0">
+                <a:solidFill>
+                  <a:srgbClr val="4C8C7E"/>
+                </a:solidFill>
+                <a:latin typeface="Calibri"/>
+              </a:rPr>
+              <a:t>결 론</a:t>
+            </a:r>
+          </a:p>
+        </p:txBody>
+      </p:sp>
+      <p:sp>
+        <p:nvSpPr>
+          <p:cNvPr id="4" name="TextBox 3"/>
+          <p:cNvSpPr txBox="1"/>
+          <p:nvPr/>
+        </p:nvSpPr>
+        <p:spPr>
+          <a:xfrm>
+            <a:off x="256032" y="5806440"/>
+            <a:ext cx="1371600" cy="914400"/>
+          </a:xfrm>
+          <a:prstGeom prst="rect">
+            <a:avLst/>
+          </a:prstGeom>
+          <a:noFill/>
+        </p:spPr>
+        <p:txBody>
+          <a:bodyPr wrap="square">
+            <a:spAutoFit/>
+          </a:bodyPr>
+          <a:lstStyle/>
+          <a:p>
+            <a:pPr algn="l">
+              <a:lnSpc>
+                <a:spcPct val="115000"/>
+              </a:lnSpc>
+            </a:pPr>
+            <a:r>
+              <a:rPr sz="4400" b="1" i="0">
+                <a:solidFill>
+                  <a:srgbClr val="FFFFFF"/>
+                </a:solidFill>
+                <a:latin typeface="Cambria"/>
+              </a:rPr>
+              <a:t>11</a:t>
+            </a:r>
+          </a:p>
+        </p:txBody>
+      </p:sp>
+      <p:sp>
+        <p:nvSpPr>
+          <p:cNvPr id="5" name="TextBox 4"/>
+          <p:cNvSpPr txBox="1"/>
+          <p:nvPr/>
+        </p:nvSpPr>
+        <p:spPr>
+          <a:xfrm>
+            <a:off x="292608" y="6473952"/>
+            <a:ext cx="1280160" cy="274320"/>
+          </a:xfrm>
+          <a:prstGeom prst="rect">
+            <a:avLst/>
+          </a:prstGeom>
+          <a:noFill/>
+        </p:spPr>
+        <p:txBody>
+          <a:bodyPr wrap="square">
+            <a:spAutoFit/>
+          </a:bodyPr>
+          <a:lstStyle/>
+          <a:p>
+            <a:pPr algn="l">
+              <a:lnSpc>
+                <a:spcPct val="115000"/>
+              </a:lnSpc>
+            </a:pPr>
+            <a:r>
+              <a:rPr sz="1100" b="0" i="0">
+                <a:solidFill>
+                  <a:srgbClr val="8B908E"/>
+                </a:solidFill>
+                <a:latin typeface="Consolas"/>
+              </a:rPr>
+              <a:t>/ 11</a:t>
             </a:r>
           </a:p>
         </p:txBody>
@@ -5409,7 +6914,7 @@
                 </a:solidFill>
                 <a:latin typeface="Consolas"/>
               </a:rPr>
-              <a:t>/ 10</a:t>
+              <a:t>/ 11</a:t>
             </a:r>
           </a:p>
         </p:txBody>
@@ -6597,7 +8102,7 @@
                 </a:solidFill>
                 <a:latin typeface="Consolas"/>
               </a:rPr>
-              <a:t>/ 10</a:t>
+              <a:t>/ 11</a:t>
             </a:r>
           </a:p>
         </p:txBody>
@@ -7663,7 +9168,7 @@
                 </a:solidFill>
                 <a:latin typeface="Consolas"/>
               </a:rPr>
-              <a:t>/ 10</a:t>
+              <a:t>/ 11</a:t>
             </a:r>
           </a:p>
         </p:txBody>
@@ -8505,7 +10010,7 @@
                 </a:solidFill>
                 <a:latin typeface="Consolas"/>
               </a:rPr>
-              <a:t>/ 10</a:t>
+              <a:t>/ 11</a:t>
             </a:r>
           </a:p>
         </p:txBody>
@@ -10083,7 +11588,7 @@
                 </a:solidFill>
                 <a:latin typeface="Consolas"/>
               </a:rPr>
-              <a:t>/ 10</a:t>
+              <a:t>/ 11</a:t>
             </a:r>
           </a:p>
         </p:txBody>
@@ -11034,7 +12539,7 @@
                 </a:solidFill>
                 <a:latin typeface="Consolas"/>
               </a:rPr>
-              <a:t>/ 10</a:t>
+              <a:t>/ 11</a:t>
             </a:r>
           </a:p>
         </p:txBody>
@@ -11497,7 +13002,7 @@
                 </a:solidFill>
                 <a:latin typeface="Consolas"/>
               </a:rPr>
-              <a:t>/ 10</a:t>
+              <a:t>/ 11</a:t>
             </a:r>
           </a:p>
         </p:txBody>
@@ -12121,7 +13626,7 @@
                 </a:solidFill>
                 <a:latin typeface="Consolas"/>
               </a:rPr>
-              <a:t>/ 10</a:t>
+              <a:t>/ 11</a:t>
             </a:r>
           </a:p>
         </p:txBody>

</xml_diff>